<commit_message>
lec-01: apply editor comments #249-#256 to rendered deck
- #249 s10 timeline: add 1956 Dartmouth ("рождение термина AI"), reflow Открытия to 4 columns
- #250 s12 stats: refresh ChatGPT WAU 900M (Feb 2026) -> ~1B (Aug 2026); other stats verified current
- #251: swap classification <-> layers slides (old 15/16)
- #252: delete ЧАТ case slide (old 20)
- #253 s22 agent: visualize inner (1 file, steps 2-6) + outer (x200) loops
- #254 s30 AGI table: verified current as of Aug 2026, no change
- #255 s34 grading: drop attendance, exam 30 -> 40 (100 = 40 + 3x20)
- #256: move semester-map + grading to front, insert MAX chat page (from sem-01) after grading, add MAX QR to Q&A slide

Edits applied in place via rendered/apply_comments_r5.py; re-rendered pptx+pdf (36 slides).

Co-Authored-By: Claude Opus 4.8 (1M context) <noreply@anthropic.com>
Claude-Session: https://claude.ai/code/session_018tLYEBvPPgPJLoyhDKhnBi
</commit_message>
<xml_diff>
--- a/library/lectures/lec-01/rendered/lec-01.pptx
+++ b/library/lectures/lec-01/rendered/lec-01.pptx
@@ -11,6 +11,9 @@
     <p:sldId id="259" r:id="rId11"/>
     <p:sldId id="260" r:id="rId12"/>
     <p:sldId id="261" r:id="rId13"/>
+    <p:sldId id="288" r:id="rId40"/>
+    <p:sldId id="289" r:id="rId41"/>
+    <p:sldId id="292" r:id="rId44"/>
     <p:sldId id="262" r:id="rId14"/>
     <p:sldId id="263" r:id="rId15"/>
     <p:sldId id="264" r:id="rId16"/>
@@ -19,12 +22,11 @@
     <p:sldId id="267" r:id="rId19"/>
     <p:sldId id="268" r:id="rId20"/>
     <p:sldId id="269" r:id="rId21"/>
+    <p:sldId id="271" r:id="rId23"/>
     <p:sldId id="270" r:id="rId22"/>
-    <p:sldId id="271" r:id="rId23"/>
     <p:sldId id="272" r:id="rId24"/>
     <p:sldId id="273" r:id="rId25"/>
     <p:sldId id="274" r:id="rId26"/>
-    <p:sldId id="275" r:id="rId27"/>
     <p:sldId id="276" r:id="rId28"/>
     <p:sldId id="277" r:id="rId29"/>
     <p:sldId id="278" r:id="rId30"/>
@@ -37,8 +39,6 @@
     <p:sldId id="285" r:id="rId37"/>
     <p:sldId id="286" r:id="rId38"/>
     <p:sldId id="287" r:id="rId39"/>
-    <p:sldId id="288" r:id="rId40"/>
-    <p:sldId id="289" r:id="rId41"/>
     <p:sldId id="290" r:id="rId42"/>
     <p:sldId id="291" r:id="rId43"/>
   </p:sldIdLst>
@@ -1620,100 +1620,6 @@
 </p:notes>
 </file>
 
-<file path=ppt/notesSlides/notesSlide20.xml><?xml version="1.0" encoding="utf-8"?>
-<p:notes xmlns:a="http://schemas.openxmlformats.org/drawingml/2006/main" xmlns:p="http://schemas.openxmlformats.org/presentationml/2006/main" xmlns:r="http://schemas.openxmlformats.org/officeDocument/2006/relationships">
-  <p:cSld>
-    <p:spTree>
-      <p:nvGrpSpPr>
-        <p:cNvPr id="1" name=""/>
-        <p:cNvGrpSpPr/>
-        <p:nvPr/>
-      </p:nvGrpSpPr>
-      <p:grpSpPr>
-        <a:xfrm>
-          <a:off x="0" y="0"/>
-          <a:ext cx="0" cy="0"/>
-          <a:chOff x="0" y="0"/>
-          <a:chExt cx="0" cy="0"/>
-        </a:xfrm>
-      </p:grpSpPr>
-      <p:sp>
-        <p:nvSpPr>
-          <p:cNvPr id="2" name="Slide Image Placeholder 1"/>
-          <p:cNvSpPr>
-            <a:spLocks noGrp="1"/>
-          </p:cNvSpPr>
-          <p:nvPr>
-            <p:ph type="sldImg" idx="2"/>
-          </p:nvPr>
-        </p:nvSpPr>
-        <p:spPr/>
-      </p:sp>
-      <p:sp>
-        <p:nvSpPr>
-          <p:cNvPr id="3" name="Notes Placeholder 2"/>
-          <p:cNvSpPr>
-            <a:spLocks noGrp="1"/>
-          </p:cNvSpPr>
-          <p:nvPr>
-            <p:ph type="body" idx="3" sz="quarter"/>
-          </p:nvPr>
-        </p:nvSpPr>
-        <p:spPr/>
-        <p:txBody>
-          <a:bodyPr/>
-          <a:lstStyle/>
-          <a:p>
-            <a:r>
-              <a:t>Чат — это модель, обёрнутая в текстовый интерфейс с памятью диалога в пределах сессии. Пользователь пишет сообщение, модель отвечает, история обоих сообщений включается в контекст следующего обращения. Это даёт ощущение разговора и позволяет уточнять задачу пошагово, что радикально меняет паттерн использования.</a:t>
-            </a:r>
-          </a:p>
-          <a:p/>
-          <a:p>
-            <a:r>
-              <a:t>Современные чаты — это в первую очередь LLM-чаты, хотя бывают и мультимодальные: с возможностью передавать изображения, аудио, файлы. Канонические продукты вы знаете: ChatGPT, Claude, Gemini, DeepSeek Chat, GigaChat, YandexGPT, Mistral Le Chat. Между ними различия в качестве для разных задач, в длине контекстного окна, в стоимости, в доступности модальностей — но базовый паттерн взаимодействия один.</a:t>
-            </a:r>
-          </a:p>
-          <a:p/>
-          <a:p>
-            <a:r>
-              <a:t>Возьмём конкретный пример. Инженер получает непонятный нормативный документ — скажем, ТЗ от смежного отдела с массой ссылок на стандарты и сложными формулировками. Задача — разобраться и составить чек-лист для собственной работы. Это типовой кейс для чата: разовая задача, требующая диалога, с уточнениями по ходу. Здесь не нужна отдельная специализированная модель, потому что нет потока однотипных задач. Не нужен агент, потому что не требуется автоматически открывать файлы и API. И нет специализированного приложения. Чат — оптимальный инструмент.</a:t>
-            </a:r>
-          </a:p>
-          <a:p/>
-          <a:p>
-            <a:r>
-              <a:t>Важная оговорка для промышленных систем. Чистые чаты в том виде, как они есть «из коробки» — то есть просто LLM плюс UI плюс короткая память сессии — в корпоративной среде почти не встречаются. Почти везде, где речь идёт о реальном внедрении, чат расширен до агента: хотя бы для того, чтобы хранить долгосрочную память между сессиями, или для того, чтобы искать ответ в корпоративной базе знаний через RAG (retrieval-augmented generation). Архитектуру агента — что именно добавляется к чату — разберём на следующем слайде.</a:t>
-            </a:r>
-          </a:p>
-          <a:p/>
-          <a:p>
-            <a:r>
-              <a:t>Выбор чата — это инженерное решение о точке на шкале взаимодействия: где правильно выбран тип взаимодействия с AI, там система работает предсказуемо.</a:t>
-            </a:r>
-          </a:p>
-        </p:txBody>
-      </p:sp>
-      <p:sp>
-        <p:nvSpPr>
-          <p:cNvPr id="4" name="Slide Number Placeholder 3"/>
-          <p:cNvSpPr>
-            <a:spLocks noGrp="1"/>
-          </p:cNvSpPr>
-          <p:nvPr>
-            <p:ph type="sldNum" idx="5" sz="quarter"/>
-          </p:nvPr>
-        </p:nvSpPr>
-        <p:spPr/>
-      </p:sp>
-    </p:spTree>
-  </p:cSld>
-  <p:clrMapOvr>
-    <a:masterClrMapping/>
-  </p:clrMapOvr>
-</p:notes>
-</file>
-
 <file path=ppt/notesSlides/notesSlide21.xml><?xml version="1.0" encoding="utf-8"?>
 <p:notes xmlns:a="http://schemas.openxmlformats.org/drawingml/2006/main" xmlns:p="http://schemas.openxmlformats.org/presentationml/2006/main" xmlns:r="http://schemas.openxmlformats.org/officeDocument/2006/relationships">
   <p:cSld>
@@ -3336,6 +3242,88 @@
           <a:p>
             <a:r>
               <a:t>Если вопросов нет — не страшно. До встречи на следующей лекции.</a:t>
+            </a:r>
+          </a:p>
+        </p:txBody>
+      </p:sp>
+      <p:sp>
+        <p:nvSpPr>
+          <p:cNvPr id="4" name="Slide Number Placeholder 3"/>
+          <p:cNvSpPr>
+            <a:spLocks noGrp="1"/>
+          </p:cNvSpPr>
+          <p:nvPr>
+            <p:ph type="sldNum" idx="5" sz="quarter"/>
+          </p:nvPr>
+        </p:nvSpPr>
+        <p:spPr/>
+      </p:sp>
+    </p:spTree>
+  </p:cSld>
+  <p:clrMapOvr>
+    <a:masterClrMapping/>
+  </p:clrMapOvr>
+</p:notes>
+</file>
+
+<file path=ppt/notesSlides/notesSlide37.xml><?xml version="1.0" encoding="utf-8"?>
+<p:notes xmlns:a="http://schemas.openxmlformats.org/drawingml/2006/main" xmlns:p="http://schemas.openxmlformats.org/presentationml/2006/main" xmlns:r="http://schemas.openxmlformats.org/officeDocument/2006/relationships">
+  <p:cSld>
+    <p:spTree>
+      <p:nvGrpSpPr>
+        <p:cNvPr id="1" name=""/>
+        <p:cNvGrpSpPr/>
+        <p:nvPr/>
+      </p:nvGrpSpPr>
+      <p:grpSpPr>
+        <a:xfrm>
+          <a:off x="0" y="0"/>
+          <a:ext cx="0" cy="0"/>
+          <a:chOff x="0" y="0"/>
+          <a:chExt cx="0" cy="0"/>
+        </a:xfrm>
+      </p:grpSpPr>
+      <p:sp>
+        <p:nvSpPr>
+          <p:cNvPr id="2" name="Slide Image Placeholder 1"/>
+          <p:cNvSpPr>
+            <a:spLocks noGrp="1"/>
+          </p:cNvSpPr>
+          <p:nvPr>
+            <p:ph type="sldImg" idx="2"/>
+          </p:nvPr>
+        </p:nvSpPr>
+        <p:spPr/>
+      </p:sp>
+      <p:sp>
+        <p:nvSpPr>
+          <p:cNvPr id="3" name="Notes Placeholder 2"/>
+          <p:cNvSpPr>
+            <a:spLocks noGrp="1"/>
+          </p:cNvSpPr>
+          <p:nvPr>
+            <p:ph type="body" idx="3" sz="quarter"/>
+          </p:nvPr>
+        </p:nvSpPr>
+        <p:spPr/>
+        <p:txBody>
+          <a:bodyPr/>
+          <a:lstStyle/>
+          <a:p>
+            <a:r>
+              <a:t>Всё общение по курсу — в чате в мессенджере MAX. Отсканируйте QR-код камерой телефона или перейдите по ссылке max.ru/join/sHoHlhI4jvW_swcq5ZLowvz6G94m0IMhAwngxuxsEpI и вступите в чат до первой лекции.</a:t>
+            </a:r>
+          </a:p>
+          <a:p/>
+          <a:p>
+            <a:r>
+              <a:t>Что там будет. Во-первых, объявления: расписание, любые изменения, важные новости — всё публикуется в чате, отдельно письма ждать не нужно. Во-вторых, материалы: слайды лекций и семинаров я выкладываю туда по мере проведения занятий, так что всё собрано в одном месте. В-третьих, вопросы: если что-то непонятно между парами — спрашивайте в чате, не обязательно копить до семинара.</a:t>
+            </a:r>
+          </a:p>
+          <a:p/>
+          <a:p>
+            <a:r>
+              <a:t>Пожалуйста, вступите сегодня — так вы точно не пропустите первое объявление.</a:t>
             </a:r>
           </a:p>
         </p:txBody>
@@ -7493,7 +7481,7 @@
         </p:nvSpPr>
         <p:spPr>
           <a:xfrm>
-            <a:off x="2607564" y="2459736"/>
+            <a:off x="2121408" y="2459736"/>
             <a:ext cx="73152" cy="201168"/>
           </a:xfrm>
           <a:prstGeom prst="rect">
@@ -7538,7 +7526,7 @@
         <p:spPr>
           <a:xfrm>
             <a:off x="914400" y="1874519"/>
-            <a:ext cx="3459480" cy="384048"/>
+            <a:ext cx="2487168" cy="658368"/>
           </a:xfrm>
           <a:prstGeom prst="rect">
             <a:avLst/>
@@ -7557,7 +7545,7 @@
               </a:lnSpc>
             </a:pPr>
             <a:r>
-              <a:rPr sz="1250" b="0" i="0">
+              <a:rPr sz="1100" b="0" i="0">
                 <a:solidFill>
                   <a:srgbClr val="21295C"/>
                 </a:solidFill>
@@ -7577,7 +7565,7 @@
         <p:spPr>
           <a:xfrm>
             <a:off x="914400" y="2606040"/>
-            <a:ext cx="3459480" cy="292608"/>
+            <a:ext cx="2487168" cy="292608"/>
           </a:xfrm>
           <a:prstGeom prst="rect">
             <a:avLst/>
@@ -7615,7 +7603,7 @@
         </p:nvSpPr>
         <p:spPr>
           <a:xfrm>
-            <a:off x="6067044" y="2459736"/>
+            <a:off x="7333488" y="2459736"/>
             <a:ext cx="73152" cy="201168"/>
           </a:xfrm>
           <a:prstGeom prst="rect">
@@ -7659,8 +7647,8 @@
         </p:nvSpPr>
         <p:spPr>
           <a:xfrm>
-            <a:off x="4373880" y="1874519"/>
-            <a:ext cx="3459480" cy="384048"/>
+            <a:off x="6126480" y="1874519"/>
+            <a:ext cx="2487168" cy="658368"/>
           </a:xfrm>
           <a:prstGeom prst="rect">
             <a:avLst/>
@@ -7679,7 +7667,7 @@
               </a:lnSpc>
             </a:pPr>
             <a:r>
-              <a:rPr sz="1250" b="0" i="0">
+              <a:rPr sz="1100" b="0" i="0">
                 <a:solidFill>
                   <a:srgbClr val="21295C"/>
                 </a:solidFill>
@@ -7698,8 +7686,8 @@
         </p:nvSpPr>
         <p:spPr>
           <a:xfrm>
-            <a:off x="4373880" y="2606040"/>
-            <a:ext cx="3459480" cy="292608"/>
+            <a:off x="6126480" y="2606040"/>
+            <a:ext cx="2487168" cy="292608"/>
           </a:xfrm>
           <a:prstGeom prst="rect">
             <a:avLst/>
@@ -7737,7 +7725,7 @@
         </p:nvSpPr>
         <p:spPr>
           <a:xfrm>
-            <a:off x="9526523" y="2459736"/>
+            <a:off x="9939528" y="2459736"/>
             <a:ext cx="73152" cy="201168"/>
           </a:xfrm>
           <a:prstGeom prst="rect">
@@ -7781,8 +7769,8 @@
         </p:nvSpPr>
         <p:spPr>
           <a:xfrm>
-            <a:off x="7833360" y="1874519"/>
-            <a:ext cx="3459480" cy="384048"/>
+            <a:off x="8732520" y="1874519"/>
+            <a:ext cx="2487168" cy="658368"/>
           </a:xfrm>
           <a:prstGeom prst="rect">
             <a:avLst/>
@@ -7801,7 +7789,7 @@
               </a:lnSpc>
             </a:pPr>
             <a:r>
-              <a:rPr sz="1250" b="0" i="0">
+              <a:rPr sz="1100" b="0" i="0">
                 <a:solidFill>
                   <a:srgbClr val="21295C"/>
                 </a:solidFill>
@@ -7820,8 +7808,8 @@
         </p:nvSpPr>
         <p:spPr>
           <a:xfrm>
-            <a:off x="7833360" y="2606040"/>
-            <a:ext cx="3459480" cy="292608"/>
+            <a:off x="8732520" y="2606040"/>
+            <a:ext cx="2487168" cy="292608"/>
           </a:xfrm>
           <a:prstGeom prst="rect">
             <a:avLst/>
@@ -9108,6 +9096,128 @@
               </a:rPr>
               <a:t>★ 2017 — Vaswani и 7 соавторов (Shazeer, Parmar, Uszkoreit, Jones, Gomez, Kaiser, Polosukhin) вводят механизм self-attention — основу всех современных LLM. На май 2026 у статьи свыше 160 000 цитирований.</a:t>
             </a:r>
+          </a:p>
+        </p:txBody>
+      </p:sp>
+      <p:sp>
+        <p:nvSpPr>
+          <p:cNvPr id="8" name="TextBox 7"/>
+          <p:cNvSpPr txBox="1"/>
+          <p:nvPr/>
+        </p:nvSpPr>
+        <p:spPr>
+          <a:xfrm>
+            <a:off x="3520440" y="1874519"/>
+            <a:ext cx="2487168" cy="658368"/>
+          </a:xfrm>
+          <a:prstGeom prst="rect">
+            <a:avLst/>
+          </a:prstGeom>
+          <a:noFill/>
+        </p:spPr>
+        <p:txBody>
+          <a:bodyPr wrap="square" lIns="0" rIns="0" tIns="0" bIns="0" anchor="t">
+            <a:spAutoFit/>
+          </a:bodyPr>
+          <a:lstStyle/>
+          <a:p>
+            <a:pPr algn="ctr">
+              <a:lnSpc>
+                <a:spcPct val="105000"/>
+              </a:lnSpc>
+            </a:pPr>
+            <a:r>
+              <a:rPr sz="1100" b="0" i="0">
+                <a:solidFill>
+                  <a:srgbClr val="21295C"/>
+                </a:solidFill>
+                <a:latin typeface="Arial"/>
+              </a:rPr>
+              <a:t>Дартмутский семинар — рождение термина «AI»</a:t>
+            </a:r>
+          </a:p>
+        </p:txBody>
+      </p:sp>
+      <p:sp>
+        <p:nvSpPr>
+          <p:cNvPr id="9" name="TextBox 8"/>
+          <p:cNvSpPr txBox="1"/>
+          <p:nvPr/>
+        </p:nvSpPr>
+        <p:spPr>
+          <a:xfrm>
+            <a:off x="3520440" y="2606040"/>
+            <a:ext cx="2487168" cy="292608"/>
+          </a:xfrm>
+          <a:prstGeom prst="rect">
+            <a:avLst/>
+          </a:prstGeom>
+          <a:noFill/>
+        </p:spPr>
+        <p:txBody>
+          <a:bodyPr wrap="square" lIns="0" rIns="0" tIns="0" bIns="0" anchor="t">
+            <a:spAutoFit/>
+          </a:bodyPr>
+          <a:lstStyle/>
+          <a:p>
+            <a:pPr algn="ctr">
+              <a:lnSpc>
+                <a:spcPct val="115000"/>
+              </a:lnSpc>
+            </a:pPr>
+            <a:r>
+              <a:rPr sz="1450" b="1" i="0">
+                <a:solidFill>
+                  <a:srgbClr val="1C7293"/>
+                </a:solidFill>
+                <a:latin typeface="Arial"/>
+              </a:rPr>
+              <a:t>1956</a:t>
+            </a:r>
+          </a:p>
+        </p:txBody>
+      </p:sp>
+      <p:sp>
+        <p:nvSpPr>
+          <p:cNvPr id="7" name="Rectangle 6"/>
+          <p:cNvSpPr/>
+          <p:nvPr/>
+        </p:nvSpPr>
+        <p:spPr>
+          <a:xfrm>
+            <a:off x="4727448" y="2459736"/>
+            <a:ext cx="73152" cy="201168"/>
+          </a:xfrm>
+          <a:prstGeom prst="rect">
+            <a:avLst/>
+          </a:prstGeom>
+          <a:solidFill>
+            <a:srgbClr val="1C7293"/>
+          </a:solidFill>
+          <a:ln>
+            <a:noFill/>
+          </a:ln>
+          <a:effectLst/>
+        </p:spPr>
+        <p:style>
+          <a:lnRef idx="1">
+            <a:schemeClr val="accent1"/>
+          </a:lnRef>
+          <a:fillRef idx="3">
+            <a:schemeClr val="accent1"/>
+          </a:fillRef>
+          <a:effectRef idx="2">
+            <a:schemeClr val="accent1"/>
+          </a:effectRef>
+          <a:fontRef idx="minor">
+            <a:schemeClr val="lt1"/>
+          </a:fontRef>
+        </p:style>
+        <p:txBody>
+          <a:bodyPr rtlCol="0" anchor="ctr"/>
+          <a:lstStyle/>
+          <a:p>
+            <a:pPr algn="ctr"/>
           </a:p>
         </p:txBody>
       </p:sp>
@@ -10266,7 +10376,7 @@
                 </a:solidFill>
                 <a:latin typeface="Arial"/>
               </a:rPr>
-              <a:t>AI стал инфраструктурой за 3 года: 900M пользователей, 51% разработчиков ежедневно, 46% Copilot-кода.</a:t>
+              <a:t>AI стал инфраструктурой за 3 года: ~1 млрд пользователей, 51% разработчиков ежедневно, 46% Copilot-кода.</a:t>
             </a:r>
           </a:p>
         </p:txBody>
@@ -10377,7 +10487,7 @@
                 </a:solidFill>
                 <a:latin typeface="Arial"/>
               </a:rPr>
-              <a:t>900M</a:t>
+              <a:t>1B</a:t>
             </a:r>
           </a:p>
         </p:txBody>
@@ -10455,7 +10565,7 @@
                 </a:solidFill>
                 <a:latin typeface="Arial"/>
               </a:rPr>
-              <a:t>ChatGPT, февраль 2026</a:t>
+              <a:t>ChatGPT, август 2026</a:t>
             </a:r>
           </a:p>
         </p:txBody>
@@ -21866,707 +21976,6 @@
 </p:sld>
 </file>
 
-<file path=ppt/slides/slide20.xml><?xml version="1.0" encoding="utf-8"?>
-<p:sld xmlns:a="http://schemas.openxmlformats.org/drawingml/2006/main" xmlns:p="http://schemas.openxmlformats.org/presentationml/2006/main" xmlns:r="http://schemas.openxmlformats.org/officeDocument/2006/relationships">
-  <p:cSld>
-    <p:spTree>
-      <p:nvGrpSpPr>
-        <p:cNvPr id="1" name=""/>
-        <p:cNvGrpSpPr/>
-        <p:nvPr/>
-      </p:nvGrpSpPr>
-      <p:grpSpPr/>
-      <p:sp>
-        <p:nvSpPr>
-          <p:cNvPr id="2" name="Rounded Rectangle 1"/>
-          <p:cNvSpPr/>
-          <p:nvPr/>
-        </p:nvSpPr>
-        <p:spPr>
-          <a:xfrm>
-            <a:off x="502920" y="320040"/>
-            <a:ext cx="758952" cy="384048"/>
-          </a:xfrm>
-          <a:prstGeom prst="roundRect">
-            <a:avLst>
-              <a:gd name="adj" fmla="val 50000"/>
-            </a:avLst>
-          </a:prstGeom>
-          <a:solidFill>
-            <a:srgbClr val="21295C"/>
-          </a:solidFill>
-          <a:ln>
-            <a:noFill/>
-          </a:ln>
-          <a:effectLst/>
-        </p:spPr>
-        <p:style>
-          <a:lnRef idx="1">
-            <a:schemeClr val="accent1"/>
-          </a:lnRef>
-          <a:fillRef idx="3">
-            <a:schemeClr val="accent1"/>
-          </a:fillRef>
-          <a:effectRef idx="2">
-            <a:schemeClr val="accent1"/>
-          </a:effectRef>
-          <a:fontRef idx="minor">
-            <a:schemeClr val="lt1"/>
-          </a:fontRef>
-        </p:style>
-        <p:txBody>
-          <a:bodyPr rtlCol="0" anchor="ctr" lIns="45720" rIns="45720" tIns="36576" bIns="36576" wrap="none"/>
-          <a:lstStyle/>
-          <a:p>
-            <a:pPr algn="ctr"/>
-            <a:r>
-              <a:rPr sz="1300" b="1">
-                <a:solidFill>
-                  <a:srgbClr val="FFFFFF"/>
-                </a:solidFill>
-                <a:latin typeface="Arial"/>
-              </a:rPr>
-              <a:t>ЧАТ</a:t>
-            </a:r>
-          </a:p>
-        </p:txBody>
-      </p:sp>
-      <p:sp>
-        <p:nvSpPr>
-          <p:cNvPr id="3" name="TextBox 2"/>
-          <p:cNvSpPr txBox="1"/>
-          <p:nvPr/>
-        </p:nvSpPr>
-        <p:spPr>
-          <a:xfrm>
-            <a:off x="502920" y="777240"/>
-            <a:ext cx="11247120" cy="1051560"/>
-          </a:xfrm>
-          <a:prstGeom prst="rect">
-            <a:avLst/>
-          </a:prstGeom>
-          <a:noFill/>
-        </p:spPr>
-        <p:txBody>
-          <a:bodyPr wrap="square" lIns="0" rIns="0" tIns="0" bIns="0" anchor="t">
-            <a:spAutoFit/>
-          </a:bodyPr>
-          <a:lstStyle/>
-          <a:p>
-            <a:pPr algn="l">
-              <a:lnSpc>
-                <a:spcPct val="118000"/>
-              </a:lnSpc>
-            </a:pPr>
-            <a:r>
-              <a:rPr sz="2800" b="1" i="0">
-                <a:solidFill>
-                  <a:srgbClr val="21295C"/>
-                </a:solidFill>
-                <a:latin typeface="Arial"/>
-              </a:rPr>
-              <a:t>Чат = модель + интерфейс + память диалога.</a:t>
-            </a:r>
-          </a:p>
-        </p:txBody>
-      </p:sp>
-      <p:sp>
-        <p:nvSpPr>
-          <p:cNvPr id="4" name="Rounded Rectangle 3"/>
-          <p:cNvSpPr/>
-          <p:nvPr/>
-        </p:nvSpPr>
-        <p:spPr>
-          <a:xfrm>
-            <a:off x="502920" y="1965960"/>
-            <a:ext cx="5943600" cy="4114800"/>
-          </a:xfrm>
-          <a:prstGeom prst="roundRect">
-            <a:avLst>
-              <a:gd name="adj" fmla="val 7407"/>
-            </a:avLst>
-          </a:prstGeom>
-          <a:solidFill>
-            <a:srgbClr val="F4F7FA"/>
-          </a:solidFill>
-          <a:ln w="19050">
-            <a:solidFill>
-              <a:srgbClr val="1C7293"/>
-            </a:solidFill>
-          </a:ln>
-          <a:effectLst/>
-        </p:spPr>
-        <p:style>
-          <a:lnRef idx="1">
-            <a:schemeClr val="accent1"/>
-          </a:lnRef>
-          <a:fillRef idx="3">
-            <a:schemeClr val="accent1"/>
-          </a:fillRef>
-          <a:effectRef idx="2">
-            <a:schemeClr val="accent1"/>
-          </a:effectRef>
-          <a:fontRef idx="minor">
-            <a:schemeClr val="lt1"/>
-          </a:fontRef>
-        </p:style>
-        <p:txBody>
-          <a:bodyPr rtlCol="0" anchor="ctr"/>
-          <a:lstStyle/>
-          <a:p>
-            <a:pPr algn="ctr"/>
-          </a:p>
-        </p:txBody>
-      </p:sp>
-      <p:sp>
-        <p:nvSpPr>
-          <p:cNvPr id="5" name="TextBox 4"/>
-          <p:cNvSpPr txBox="1"/>
-          <p:nvPr/>
-        </p:nvSpPr>
-        <p:spPr>
-          <a:xfrm>
-            <a:off x="777240" y="2194560"/>
-            <a:ext cx="5394960" cy="365760"/>
-          </a:xfrm>
-          <a:prstGeom prst="rect">
-            <a:avLst/>
-          </a:prstGeom>
-          <a:noFill/>
-        </p:spPr>
-        <p:txBody>
-          <a:bodyPr wrap="square" lIns="0" rIns="0" tIns="0" bIns="0" anchor="t">
-            <a:spAutoFit/>
-          </a:bodyPr>
-          <a:lstStyle/>
-          <a:p>
-            <a:pPr algn="l">
-              <a:lnSpc>
-                <a:spcPct val="115000"/>
-              </a:lnSpc>
-            </a:pPr>
-            <a:r>
-              <a:rPr sz="1400" b="1" i="0">
-                <a:solidFill>
-                  <a:srgbClr val="028090"/>
-                </a:solidFill>
-                <a:latin typeface="Arial"/>
-              </a:rPr>
-              <a:t>Кейс — типовой для чата</a:t>
-            </a:r>
-          </a:p>
-        </p:txBody>
-      </p:sp>
-      <p:sp>
-        <p:nvSpPr>
-          <p:cNvPr id="6" name="TextBox 5"/>
-          <p:cNvSpPr txBox="1"/>
-          <p:nvPr/>
-        </p:nvSpPr>
-        <p:spPr>
-          <a:xfrm>
-            <a:off x="777240" y="2606039"/>
-            <a:ext cx="5394960" cy="868680"/>
-          </a:xfrm>
-          <a:prstGeom prst="rect">
-            <a:avLst/>
-          </a:prstGeom>
-          <a:noFill/>
-        </p:spPr>
-        <p:txBody>
-          <a:bodyPr wrap="square" lIns="0" rIns="0" tIns="0" bIns="0" anchor="t">
-            <a:spAutoFit/>
-          </a:bodyPr>
-          <a:lstStyle/>
-          <a:p>
-            <a:pPr algn="l">
-              <a:lnSpc>
-                <a:spcPct val="130000"/>
-              </a:lnSpc>
-            </a:pPr>
-            <a:r>
-              <a:rPr sz="1500" b="0" i="0">
-                <a:solidFill>
-                  <a:srgbClr val="21295C"/>
-                </a:solidFill>
-                <a:latin typeface="Arial"/>
-              </a:rPr>
-              <a:t>Инженер получил непонятное ТЗ от смежного отдела, нужно составить чек-лист своей работы.</a:t>
-            </a:r>
-          </a:p>
-        </p:txBody>
-      </p:sp>
-      <p:sp>
-        <p:nvSpPr>
-          <p:cNvPr id="7" name="Rounded Rectangle 6"/>
-          <p:cNvSpPr/>
-          <p:nvPr/>
-        </p:nvSpPr>
-        <p:spPr>
-          <a:xfrm>
-            <a:off x="868680" y="3657600"/>
-            <a:ext cx="5212080" cy="1828800"/>
-          </a:xfrm>
-          <a:prstGeom prst="roundRect">
-            <a:avLst>
-              <a:gd name="adj" fmla="val 8000"/>
-            </a:avLst>
-          </a:prstGeom>
-          <a:solidFill>
-            <a:srgbClr val="FFFFFF"/>
-          </a:solidFill>
-          <a:ln w="12700">
-            <a:solidFill>
-              <a:srgbClr val="E5EAF0"/>
-            </a:solidFill>
-          </a:ln>
-          <a:effectLst/>
-        </p:spPr>
-        <p:style>
-          <a:lnRef idx="1">
-            <a:schemeClr val="accent1"/>
-          </a:lnRef>
-          <a:fillRef idx="3">
-            <a:schemeClr val="accent1"/>
-          </a:fillRef>
-          <a:effectRef idx="2">
-            <a:schemeClr val="accent1"/>
-          </a:effectRef>
-          <a:fontRef idx="minor">
-            <a:schemeClr val="lt1"/>
-          </a:fontRef>
-        </p:style>
-        <p:txBody>
-          <a:bodyPr rtlCol="0" anchor="ctr"/>
-          <a:lstStyle/>
-          <a:p>
-            <a:pPr algn="ctr"/>
-          </a:p>
-        </p:txBody>
-      </p:sp>
-      <p:sp>
-        <p:nvSpPr>
-          <p:cNvPr id="8" name="TextBox 7"/>
-          <p:cNvSpPr txBox="1"/>
-          <p:nvPr/>
-        </p:nvSpPr>
-        <p:spPr>
-          <a:xfrm>
-            <a:off x="1051560" y="3794760"/>
-            <a:ext cx="4846320" cy="1554480"/>
-          </a:xfrm>
-          <a:prstGeom prst="rect">
-            <a:avLst/>
-          </a:prstGeom>
-          <a:noFill/>
-        </p:spPr>
-        <p:txBody>
-          <a:bodyPr wrap="square" lIns="0" rIns="0" tIns="0" bIns="0" anchor="t">
-            <a:spAutoFit/>
-          </a:bodyPr>
-          <a:lstStyle/>
-          <a:p>
-            <a:pPr algn="l">
-              <a:lnSpc>
-                <a:spcPct val="145000"/>
-              </a:lnSpc>
-            </a:pPr>
-            <a:r>
-              <a:rPr sz="1200" b="1" i="0">
-                <a:solidFill>
-                  <a:srgbClr val="065A82"/>
-                </a:solidFill>
-                <a:latin typeface="Arial"/>
-              </a:rPr>
-              <a:t>Вы:  </a:t>
-            </a:r>
-            <a:r>
-              <a:rPr sz="1200" b="0" i="0">
-                <a:solidFill>
-                  <a:srgbClr val="21295C"/>
-                </a:solidFill>
-                <a:latin typeface="Arial"/>
-              </a:rPr>
-              <a:t>Объясни пункт 4.2 ТЗ простыми словами.</a:t>
-            </a:r>
-          </a:p>
-          <a:p>
-            <a:pPr algn="l">
-              <a:lnSpc>
-                <a:spcPct val="145000"/>
-              </a:lnSpc>
-            </a:pPr>
-            <a:r>
-              <a:rPr sz="1200" b="1" i="0">
-                <a:solidFill>
-                  <a:srgbClr val="028090"/>
-                </a:solidFill>
-                <a:latin typeface="Arial"/>
-              </a:rPr>
-              <a:t>Чат:  </a:t>
-            </a:r>
-            <a:r>
-              <a:rPr sz="1200" b="0" i="0">
-                <a:solidFill>
-                  <a:srgbClr val="21295C"/>
-                </a:solidFill>
-                <a:latin typeface="Arial"/>
-              </a:rPr>
-              <a:t>Это требование к…</a:t>
-            </a:r>
-          </a:p>
-          <a:p>
-            <a:pPr algn="l">
-              <a:lnSpc>
-                <a:spcPct val="145000"/>
-              </a:lnSpc>
-            </a:pPr>
-            <a:r>
-              <a:rPr sz="1200" b="1" i="0">
-                <a:solidFill>
-                  <a:srgbClr val="065A82"/>
-                </a:solidFill>
-                <a:latin typeface="Arial"/>
-              </a:rPr>
-              <a:t>Вы:  </a:t>
-            </a:r>
-            <a:r>
-              <a:rPr sz="1200" b="0" i="0">
-                <a:solidFill>
-                  <a:srgbClr val="21295C"/>
-                </a:solidFill>
-                <a:latin typeface="Arial"/>
-              </a:rPr>
-              <a:t>Составь чек-лист на 5 пунктов.</a:t>
-            </a:r>
-          </a:p>
-          <a:p>
-            <a:pPr algn="l">
-              <a:lnSpc>
-                <a:spcPct val="145000"/>
-              </a:lnSpc>
-            </a:pPr>
-            <a:r>
-              <a:rPr sz="1200" b="1" i="0">
-                <a:solidFill>
-                  <a:srgbClr val="028090"/>
-                </a:solidFill>
-                <a:latin typeface="Arial"/>
-              </a:rPr>
-              <a:t>Чат:  </a:t>
-            </a:r>
-            <a:r>
-              <a:rPr sz="1200" b="0" i="0">
-                <a:solidFill>
-                  <a:srgbClr val="21295C"/>
-                </a:solidFill>
-                <a:latin typeface="Arial"/>
-              </a:rPr>
-              <a:t>1. Проверить…  2. Согласовать…  3. …</a:t>
-            </a:r>
-          </a:p>
-        </p:txBody>
-      </p:sp>
-      <p:sp>
-        <p:nvSpPr>
-          <p:cNvPr id="9" name="TextBox 8"/>
-          <p:cNvSpPr txBox="1"/>
-          <p:nvPr/>
-        </p:nvSpPr>
-        <p:spPr>
-          <a:xfrm>
-            <a:off x="777240" y="5623560"/>
-            <a:ext cx="5394960" cy="320040"/>
-          </a:xfrm>
-          <a:prstGeom prst="rect">
-            <a:avLst/>
-          </a:prstGeom>
-          <a:noFill/>
-        </p:spPr>
-        <p:txBody>
-          <a:bodyPr wrap="square" lIns="0" rIns="0" tIns="0" bIns="0" anchor="t">
-            <a:spAutoFit/>
-          </a:bodyPr>
-          <a:lstStyle/>
-          <a:p>
-            <a:pPr algn="l">
-              <a:lnSpc>
-                <a:spcPct val="130000"/>
-              </a:lnSpc>
-            </a:pPr>
-            <a:r>
-              <a:rPr sz="1100" b="0" i="1">
-                <a:solidFill>
-                  <a:srgbClr val="1C7293"/>
-                </a:solidFill>
-                <a:latin typeface="Arial"/>
-              </a:rPr>
-              <a:t>Разовая задача с уточнениями — оптимально для чата. Не модель, не агент, не приложение.</a:t>
-            </a:r>
-          </a:p>
-        </p:txBody>
-      </p:sp>
-      <p:sp>
-        <p:nvSpPr>
-          <p:cNvPr id="10" name="Rounded Rectangle 9"/>
-          <p:cNvSpPr/>
-          <p:nvPr/>
-        </p:nvSpPr>
-        <p:spPr>
-          <a:xfrm>
-            <a:off x="6766559" y="1965960"/>
-            <a:ext cx="4937760" cy="4114800"/>
-          </a:xfrm>
-          <a:prstGeom prst="roundRect">
-            <a:avLst>
-              <a:gd name="adj" fmla="val 7407"/>
-            </a:avLst>
-          </a:prstGeom>
-          <a:solidFill>
-            <a:srgbClr val="FEF5E0"/>
-          </a:solidFill>
-          <a:ln w="19050">
-            <a:solidFill>
-              <a:srgbClr val="F0AB00"/>
-            </a:solidFill>
-          </a:ln>
-          <a:effectLst/>
-        </p:spPr>
-        <p:style>
-          <a:lnRef idx="1">
-            <a:schemeClr val="accent1"/>
-          </a:lnRef>
-          <a:fillRef idx="3">
-            <a:schemeClr val="accent1"/>
-          </a:fillRef>
-          <a:effectRef idx="2">
-            <a:schemeClr val="accent1"/>
-          </a:effectRef>
-          <a:fontRef idx="minor">
-            <a:schemeClr val="lt1"/>
-          </a:fontRef>
-        </p:style>
-        <p:txBody>
-          <a:bodyPr rtlCol="0" anchor="ctr"/>
-          <a:lstStyle/>
-          <a:p>
-            <a:pPr algn="ctr"/>
-          </a:p>
-        </p:txBody>
-      </p:sp>
-      <p:sp>
-        <p:nvSpPr>
-          <p:cNvPr id="11" name="TextBox 10"/>
-          <p:cNvSpPr txBox="1"/>
-          <p:nvPr/>
-        </p:nvSpPr>
-        <p:spPr>
-          <a:xfrm>
-            <a:off x="7040879" y="2194560"/>
-            <a:ext cx="4389120" cy="365760"/>
-          </a:xfrm>
-          <a:prstGeom prst="rect">
-            <a:avLst/>
-          </a:prstGeom>
-          <a:noFill/>
-        </p:spPr>
-        <p:txBody>
-          <a:bodyPr wrap="square" lIns="0" rIns="0" tIns="0" bIns="0" anchor="t">
-            <a:spAutoFit/>
-          </a:bodyPr>
-          <a:lstStyle/>
-          <a:p>
-            <a:pPr algn="l">
-              <a:lnSpc>
-                <a:spcPct val="115000"/>
-              </a:lnSpc>
-            </a:pPr>
-            <a:r>
-              <a:rPr sz="1400" b="1" i="0">
-                <a:solidFill>
-                  <a:srgbClr val="21295C"/>
-                </a:solidFill>
-                <a:latin typeface="Arial"/>
-              </a:rPr>
-              <a:t>Оговорка для промышленных систем</a:t>
-            </a:r>
-          </a:p>
-        </p:txBody>
-      </p:sp>
-      <p:sp>
-        <p:nvSpPr>
-          <p:cNvPr id="12" name="TextBox 11"/>
-          <p:cNvSpPr txBox="1"/>
-          <p:nvPr/>
-        </p:nvSpPr>
-        <p:spPr>
-          <a:xfrm>
-            <a:off x="7040879" y="2743200"/>
-            <a:ext cx="4389120" cy="1280160"/>
-          </a:xfrm>
-          <a:prstGeom prst="rect">
-            <a:avLst/>
-          </a:prstGeom>
-          <a:noFill/>
-        </p:spPr>
-        <p:txBody>
-          <a:bodyPr wrap="square" lIns="0" rIns="0" tIns="0" bIns="0" anchor="t">
-            <a:spAutoFit/>
-          </a:bodyPr>
-          <a:lstStyle/>
-          <a:p>
-            <a:pPr algn="l">
-              <a:lnSpc>
-                <a:spcPct val="125000"/>
-              </a:lnSpc>
-            </a:pPr>
-            <a:r>
-              <a:rPr sz="1600" b="1" i="0">
-                <a:solidFill>
-                  <a:srgbClr val="21295C"/>
-                </a:solidFill>
-                <a:latin typeface="Arial"/>
-              </a:rPr>
-              <a:t>Чистые чаты почти не используются в промышленной эксплуатации.</a:t>
-            </a:r>
-          </a:p>
-        </p:txBody>
-      </p:sp>
-      <p:sp>
-        <p:nvSpPr>
-          <p:cNvPr id="13" name="TextBox 12"/>
-          <p:cNvSpPr txBox="1"/>
-          <p:nvPr/>
-        </p:nvSpPr>
-        <p:spPr>
-          <a:xfrm>
-            <a:off x="7040879" y="4114800"/>
-            <a:ext cx="4389120" cy="1828800"/>
-          </a:xfrm>
-          <a:prstGeom prst="rect">
-            <a:avLst/>
-          </a:prstGeom>
-          <a:noFill/>
-        </p:spPr>
-        <p:txBody>
-          <a:bodyPr wrap="square" lIns="0" rIns="0" tIns="0" bIns="0" anchor="t">
-            <a:spAutoFit/>
-          </a:bodyPr>
-          <a:lstStyle/>
-          <a:p>
-            <a:pPr algn="l">
-              <a:lnSpc>
-                <a:spcPct val="140000"/>
-              </a:lnSpc>
-            </a:pPr>
-            <a:r>
-              <a:rPr sz="1200" b="0" i="0">
-                <a:solidFill>
-                  <a:srgbClr val="21295C"/>
-                </a:solidFill>
-                <a:latin typeface="Arial"/>
-              </a:rPr>
-              <a:t>Почти везде они расширены до агентов — хотя бы для долгосрочной памяти и поиска по корпоративной базе (RAG).
-Архитектуру агента разберём на следующем слайде.</a:t>
-            </a:r>
-          </a:p>
-        </p:txBody>
-      </p:sp>
-      <p:sp>
-        <p:nvSpPr>
-          <p:cNvPr id="14" name="Rounded Rectangle 13"/>
-          <p:cNvSpPr/>
-          <p:nvPr/>
-        </p:nvSpPr>
-        <p:spPr>
-          <a:xfrm>
-            <a:off x="502920" y="6172200"/>
-            <a:ext cx="11201400" cy="457200"/>
-          </a:xfrm>
-          <a:prstGeom prst="roundRect">
-            <a:avLst>
-              <a:gd name="adj" fmla="val 12000"/>
-            </a:avLst>
-          </a:prstGeom>
-          <a:solidFill>
-            <a:srgbClr val="FEF5E0"/>
-          </a:solidFill>
-          <a:ln w="15240">
-            <a:solidFill>
-              <a:srgbClr val="F0AB00"/>
-            </a:solidFill>
-          </a:ln>
-          <a:effectLst/>
-        </p:spPr>
-        <p:style>
-          <a:lnRef idx="1">
-            <a:schemeClr val="accent1"/>
-          </a:lnRef>
-          <a:fillRef idx="3">
-            <a:schemeClr val="accent1"/>
-          </a:fillRef>
-          <a:effectRef idx="2">
-            <a:schemeClr val="accent1"/>
-          </a:effectRef>
-          <a:fontRef idx="minor">
-            <a:schemeClr val="lt1"/>
-          </a:fontRef>
-        </p:style>
-        <p:txBody>
-          <a:bodyPr rtlCol="0" anchor="ctr"/>
-          <a:lstStyle/>
-          <a:p>
-            <a:pPr algn="ctr"/>
-          </a:p>
-        </p:txBody>
-      </p:sp>
-      <p:sp>
-        <p:nvSpPr>
-          <p:cNvPr id="15" name="TextBox 14"/>
-          <p:cNvSpPr txBox="1"/>
-          <p:nvPr/>
-        </p:nvSpPr>
-        <p:spPr>
-          <a:xfrm>
-            <a:off x="685800" y="6245352"/>
-            <a:ext cx="10835640" cy="310896"/>
-          </a:xfrm>
-          <a:prstGeom prst="rect">
-            <a:avLst/>
-          </a:prstGeom>
-          <a:noFill/>
-        </p:spPr>
-        <p:txBody>
-          <a:bodyPr wrap="square" lIns="0" rIns="0" tIns="0" bIns="0" anchor="ctr">
-            <a:spAutoFit/>
-          </a:bodyPr>
-          <a:lstStyle/>
-          <a:p>
-            <a:pPr algn="l">
-              <a:lnSpc>
-                <a:spcPct val="125000"/>
-              </a:lnSpc>
-            </a:pPr>
-            <a:r>
-              <a:rPr sz="1300" b="1" i="0">
-                <a:solidFill>
-                  <a:srgbClr val="21295C"/>
-                </a:solidFill>
-                <a:latin typeface="Arial"/>
-              </a:rPr>
-              <a:t>Выбор чата — точка на шкале взаимодействия, не единственно верный вариант.</a:t>
-            </a:r>
-          </a:p>
-        </p:txBody>
-      </p:sp>
-    </p:spTree>
-  </p:cSld>
-  <p:clrMapOvr>
-    <a:masterClrMapping/>
-  </p:clrMapOvr>
-</p:sld>
-</file>
-
 <file path=ppt/slides/slide21.xml><?xml version="1.0" encoding="utf-8"?>
 <p:sld xmlns:a="http://schemas.openxmlformats.org/drawingml/2006/main" xmlns:p="http://schemas.openxmlformats.org/presentationml/2006/main" xmlns:r="http://schemas.openxmlformats.org/officeDocument/2006/relationships">
   <p:cSld>
@@ -26190,6 +25599,274 @@
                 <a:latin typeface="Arial"/>
               </a:rPr>
               <a:t>Агент = последовательность вызовов инструментов, оркестрируемая LLM.</a:t>
+            </a:r>
+          </a:p>
+        </p:txBody>
+      </p:sp>
+      <p:sp>
+        <p:nvSpPr>
+          <p:cNvPr id="47" name="Rounded Rectangle 46"/>
+          <p:cNvSpPr/>
+          <p:nvPr/>
+        </p:nvSpPr>
+        <p:spPr>
+          <a:xfrm>
+            <a:off x="4599432" y="2788920"/>
+            <a:ext cx="7004304" cy="2606040"/>
+          </a:xfrm>
+          <a:prstGeom prst="roundRect">
+            <a:avLst>
+              <a:gd name="adj" fmla="val 5000"/>
+            </a:avLst>
+          </a:prstGeom>
+          <a:noFill/>
+          <a:ln w="20320">
+            <a:solidFill>
+              <a:srgbClr val="028090"/>
+            </a:solidFill>
+            <a:prstDash val="dash"/>
+          </a:ln>
+          <a:effectLst/>
+        </p:spPr>
+        <p:style>
+          <a:lnRef idx="1">
+            <a:schemeClr val="accent1"/>
+          </a:lnRef>
+          <a:fillRef idx="3">
+            <a:schemeClr val="accent1"/>
+          </a:fillRef>
+          <a:effectRef idx="2">
+            <a:schemeClr val="accent1"/>
+          </a:effectRef>
+          <a:fontRef idx="minor">
+            <a:schemeClr val="lt1"/>
+          </a:fontRef>
+        </p:style>
+        <p:txBody>
+          <a:bodyPr rtlCol="0" anchor="ctr"/>
+          <a:lstStyle/>
+          <a:p>
+            <a:pPr algn="ctr"/>
+          </a:p>
+        </p:txBody>
+      </p:sp>
+      <p:sp>
+        <p:nvSpPr>
+          <p:cNvPr id="48" name="TextBox 47"/>
+          <p:cNvSpPr txBox="1"/>
+          <p:nvPr/>
+        </p:nvSpPr>
+        <p:spPr>
+          <a:xfrm rot="16200000">
+            <a:off x="10744200" y="3611880"/>
+            <a:ext cx="2377440" cy="365760"/>
+          </a:xfrm>
+          <a:prstGeom prst="rect">
+            <a:avLst/>
+          </a:prstGeom>
+          <a:noFill/>
+        </p:spPr>
+        <p:txBody>
+          <a:bodyPr wrap="none">
+            <a:spAutoFit/>
+          </a:bodyPr>
+          <a:lstStyle/>
+          <a:p>
+            <a:pPr algn="ctr"/>
+            <a:r>
+              <a:rPr sz="1100" b="1">
+                <a:solidFill>
+                  <a:srgbClr val="028090"/>
+                </a:solidFill>
+              </a:rPr>
+              <a:t>цикл: обработка одного файла</a:t>
+            </a:r>
+          </a:p>
+        </p:txBody>
+      </p:sp>
+      <p:sp>
+        <p:nvSpPr>
+          <p:cNvPr id="49" name="Rectangle 48"/>
+          <p:cNvSpPr/>
+          <p:nvPr/>
+        </p:nvSpPr>
+        <p:spPr>
+          <a:xfrm>
+            <a:off x="4539996" y="3017520"/>
+            <a:ext cx="50292" cy="2743200"/>
+          </a:xfrm>
+          <a:prstGeom prst="rect">
+            <a:avLst/>
+          </a:prstGeom>
+          <a:solidFill>
+            <a:srgbClr val="028090"/>
+          </a:solidFill>
+          <a:ln>
+            <a:noFill/>
+          </a:ln>
+          <a:effectLst/>
+        </p:spPr>
+        <p:style>
+          <a:lnRef idx="1">
+            <a:schemeClr val="accent1"/>
+          </a:lnRef>
+          <a:fillRef idx="3">
+            <a:schemeClr val="accent1"/>
+          </a:fillRef>
+          <a:effectRef idx="2">
+            <a:schemeClr val="accent1"/>
+          </a:effectRef>
+          <a:fontRef idx="minor">
+            <a:schemeClr val="lt1"/>
+          </a:fontRef>
+        </p:style>
+        <p:txBody>
+          <a:bodyPr rtlCol="0" anchor="ctr"/>
+          <a:lstStyle/>
+          <a:p>
+            <a:pPr algn="ctr"/>
+          </a:p>
+        </p:txBody>
+      </p:sp>
+      <p:sp>
+        <p:nvSpPr>
+          <p:cNvPr id="50" name="Rectangle 49"/>
+          <p:cNvSpPr/>
+          <p:nvPr/>
+        </p:nvSpPr>
+        <p:spPr>
+          <a:xfrm>
+            <a:off x="4539996" y="5715000"/>
+            <a:ext cx="274320" cy="50292"/>
+          </a:xfrm>
+          <a:prstGeom prst="rect">
+            <a:avLst/>
+          </a:prstGeom>
+          <a:solidFill>
+            <a:srgbClr val="028090"/>
+          </a:solidFill>
+          <a:ln>
+            <a:noFill/>
+          </a:ln>
+          <a:effectLst/>
+        </p:spPr>
+        <p:style>
+          <a:lnRef idx="1">
+            <a:schemeClr val="accent1"/>
+          </a:lnRef>
+          <a:fillRef idx="3">
+            <a:schemeClr val="accent1"/>
+          </a:fillRef>
+          <a:effectRef idx="2">
+            <a:schemeClr val="accent1"/>
+          </a:effectRef>
+          <a:fontRef idx="minor">
+            <a:schemeClr val="lt1"/>
+          </a:fontRef>
+        </p:style>
+        <p:txBody>
+          <a:bodyPr rtlCol="0" anchor="ctr"/>
+          <a:lstStyle/>
+          <a:p>
+            <a:pPr algn="ctr"/>
+          </a:p>
+        </p:txBody>
+      </p:sp>
+      <p:sp>
+        <p:nvSpPr>
+          <p:cNvPr id="51" name="Isosceles Triangle 50"/>
+          <p:cNvSpPr/>
+          <p:nvPr/>
+        </p:nvSpPr>
+        <p:spPr>
+          <a:xfrm>
+            <a:off x="4485132" y="2834640"/>
+            <a:ext cx="164592" cy="201168"/>
+          </a:xfrm>
+          <a:prstGeom prst="triangle">
+            <a:avLst/>
+          </a:prstGeom>
+          <a:solidFill>
+            <a:srgbClr val="028090"/>
+          </a:solidFill>
+          <a:ln>
+            <a:noFill/>
+          </a:ln>
+          <a:effectLst/>
+        </p:spPr>
+        <p:style>
+          <a:lnRef idx="1">
+            <a:schemeClr val="accent1"/>
+          </a:lnRef>
+          <a:fillRef idx="3">
+            <a:schemeClr val="accent1"/>
+          </a:fillRef>
+          <a:effectRef idx="2">
+            <a:schemeClr val="accent1"/>
+          </a:effectRef>
+          <a:fontRef idx="minor">
+            <a:schemeClr val="lt1"/>
+          </a:fontRef>
+        </p:style>
+        <p:txBody>
+          <a:bodyPr rtlCol="0" anchor="ctr"/>
+          <a:lstStyle/>
+          <a:p>
+            <a:pPr algn="ctr"/>
+          </a:p>
+        </p:txBody>
+      </p:sp>
+      <p:sp>
+        <p:nvSpPr>
+          <p:cNvPr id="52" name="Rounded Rectangle 51"/>
+          <p:cNvSpPr/>
+          <p:nvPr/>
+        </p:nvSpPr>
+        <p:spPr>
+          <a:xfrm>
+            <a:off x="4754880" y="5907024"/>
+            <a:ext cx="2331720" cy="292608"/>
+          </a:xfrm>
+          <a:prstGeom prst="roundRect">
+            <a:avLst>
+              <a:gd name="adj" fmla="val 50000"/>
+            </a:avLst>
+          </a:prstGeom>
+          <a:solidFill>
+            <a:srgbClr val="F0AB00"/>
+          </a:solidFill>
+          <a:ln>
+            <a:noFill/>
+          </a:ln>
+          <a:effectLst/>
+        </p:spPr>
+        <p:style>
+          <a:lnRef idx="1">
+            <a:schemeClr val="accent1"/>
+          </a:lnRef>
+          <a:fillRef idx="3">
+            <a:schemeClr val="accent1"/>
+          </a:fillRef>
+          <a:effectRef idx="2">
+            <a:schemeClr val="accent1"/>
+          </a:effectRef>
+          <a:fontRef idx="minor">
+            <a:schemeClr val="lt1"/>
+          </a:fontRef>
+        </p:style>
+        <p:txBody>
+          <a:bodyPr rtlCol="0" anchor="ctr" lIns="45720" rIns="45720" tIns="36576" bIns="36576" wrap="none"/>
+          <a:lstStyle/>
+          <a:p>
+            <a:pPr algn="ctr"/>
+            <a:r>
+              <a:rPr sz="1100" b="1">
+                <a:solidFill>
+                  <a:srgbClr val="21295C"/>
+                </a:solidFill>
+                <a:latin typeface="Arial"/>
+              </a:rPr>
+              <a:t>↻  повторить × 200 файлов</a:t>
             </a:r>
           </a:p>
         </p:txBody>
@@ -39086,7 +38763,7 @@
                 </a:solidFill>
                 <a:latin typeface="Arial"/>
               </a:rPr>
-              <a:t>  =  10 </a:t>
+              <a:t>  =  40 </a:t>
             </a:r>
             <a:r>
               <a:rPr sz="1400" b="0" i="1">
@@ -39095,7 +38772,7 @@
                 </a:solidFill>
                 <a:latin typeface="Arial"/>
               </a:rPr>
-              <a:t>(посещаемость)</a:t>
+              <a:t>(экзамен)</a:t>
             </a:r>
             <a:r>
               <a:rPr sz="3000" b="1" i="0">
@@ -39104,7 +38781,7 @@
                 </a:solidFill>
                 <a:latin typeface="Arial"/>
               </a:rPr>
-              <a:t>  +  30 </a:t>
+              <a:t/>
             </a:r>
             <a:r>
               <a:rPr sz="1400" b="0" i="1">
@@ -39113,7 +38790,7 @@
                 </a:solidFill>
                 <a:latin typeface="Arial"/>
               </a:rPr>
-              <a:t>(экзамен)</a:t>
+              <a:t/>
             </a:r>
             <a:r>
               <a:rPr sz="3000" b="1" i="0">
@@ -39971,6 +39648,1015 @@
                 <a:latin typeface="Arial"/>
               </a:rPr>
               <a:t>Спасибо</a:t>
+            </a:r>
+          </a:p>
+        </p:txBody>
+      </p:sp>
+      <p:sp>
+        <p:nvSpPr>
+          <p:cNvPr id="4" name="Rounded Rectangle 3"/>
+          <p:cNvSpPr/>
+          <p:nvPr/>
+        </p:nvSpPr>
+        <p:spPr>
+          <a:xfrm>
+            <a:off x="8869680" y="4160520"/>
+            <a:ext cx="2834640" cy="2377440"/>
+          </a:xfrm>
+          <a:prstGeom prst="roundRect">
+            <a:avLst>
+              <a:gd name="adj" fmla="val 12820"/>
+            </a:avLst>
+          </a:prstGeom>
+          <a:solidFill>
+            <a:srgbClr val="FFFFFF"/>
+          </a:solidFill>
+          <a:ln w="20320">
+            <a:solidFill>
+              <a:srgbClr val="1C7293"/>
+            </a:solidFill>
+          </a:ln>
+          <a:effectLst/>
+        </p:spPr>
+        <p:style>
+          <a:lnRef idx="1">
+            <a:schemeClr val="accent1"/>
+          </a:lnRef>
+          <a:fillRef idx="3">
+            <a:schemeClr val="accent1"/>
+          </a:fillRef>
+          <a:effectRef idx="2">
+            <a:schemeClr val="accent1"/>
+          </a:effectRef>
+          <a:fontRef idx="minor">
+            <a:schemeClr val="lt1"/>
+          </a:fontRef>
+        </p:style>
+        <p:txBody>
+          <a:bodyPr rtlCol="0" anchor="ctr"/>
+          <a:lstStyle/>
+          <a:p>
+            <a:pPr algn="ctr"/>
+          </a:p>
+        </p:txBody>
+      </p:sp>
+      <p:pic>
+        <p:nvPicPr>
+          <p:cNvPr id="5" name="Picture 4" descr="max-qr.png"/>
+          <p:cNvPicPr>
+            <a:picLocks noChangeAspect="1"/>
+          </p:cNvPicPr>
+          <p:nvPr/>
+        </p:nvPicPr>
+        <p:blipFill>
+          <a:blip r:embed="rId3"/>
+          <a:stretch>
+            <a:fillRect/>
+          </a:stretch>
+        </p:blipFill>
+        <p:spPr>
+          <a:xfrm>
+            <a:off x="9578340" y="4361688"/>
+            <a:ext cx="1417320" cy="1417320"/>
+          </a:xfrm>
+          <a:prstGeom prst="rect">
+            <a:avLst/>
+          </a:prstGeom>
+        </p:spPr>
+      </p:pic>
+      <p:sp>
+        <p:nvSpPr>
+          <p:cNvPr id="6" name="TextBox 5"/>
+          <p:cNvSpPr txBox="1"/>
+          <p:nvPr/>
+        </p:nvSpPr>
+        <p:spPr>
+          <a:xfrm>
+            <a:off x="9006840" y="5861304"/>
+            <a:ext cx="2560320" cy="292608"/>
+          </a:xfrm>
+          <a:prstGeom prst="rect">
+            <a:avLst/>
+          </a:prstGeom>
+          <a:noFill/>
+        </p:spPr>
+        <p:txBody>
+          <a:bodyPr wrap="square" lIns="0" rIns="0" tIns="0" bIns="0" anchor="t">
+            <a:spAutoFit/>
+          </a:bodyPr>
+          <a:lstStyle/>
+          <a:p>
+            <a:pPr algn="ctr">
+              <a:lnSpc>
+                <a:spcPct val="115000"/>
+              </a:lnSpc>
+            </a:pPr>
+            <a:r>
+              <a:rPr sz="1300" b="1" i="0">
+                <a:solidFill>
+                  <a:srgbClr val="21295C"/>
+                </a:solidFill>
+                <a:latin typeface="Arial"/>
+              </a:rPr>
+              <a:t>Чат курса в MAX</a:t>
+            </a:r>
+          </a:p>
+        </p:txBody>
+      </p:sp>
+      <p:sp>
+        <p:nvSpPr>
+          <p:cNvPr id="7" name="TextBox 6"/>
+          <p:cNvSpPr txBox="1"/>
+          <p:nvPr/>
+        </p:nvSpPr>
+        <p:spPr>
+          <a:xfrm>
+            <a:off x="8979407" y="6135624"/>
+            <a:ext cx="2615184" cy="365760"/>
+          </a:xfrm>
+          <a:prstGeom prst="rect">
+            <a:avLst/>
+          </a:prstGeom>
+          <a:noFill/>
+        </p:spPr>
+        <p:txBody>
+          <a:bodyPr wrap="square" lIns="0" rIns="0" tIns="0" bIns="0" anchor="t">
+            <a:spAutoFit/>
+          </a:bodyPr>
+          <a:lstStyle/>
+          <a:p>
+            <a:pPr algn="ctr">
+              <a:lnSpc>
+                <a:spcPct val="115000"/>
+              </a:lnSpc>
+            </a:pPr>
+            <a:r>
+              <a:rPr sz="950" b="0" i="0">
+                <a:solidFill>
+                  <a:srgbClr val="065A82"/>
+                </a:solidFill>
+                <a:latin typeface="Arial"/>
+              </a:rPr>
+              <a:t>max.ru/join/sHoHlhI4jvW…</a:t>
+            </a:r>
+          </a:p>
+        </p:txBody>
+      </p:sp>
+    </p:spTree>
+  </p:cSld>
+  <p:clrMapOvr>
+    <a:masterClrMapping/>
+  </p:clrMapOvr>
+</p:sld>
+</file>
+
+<file path=ppt/slides/slide37.xml><?xml version="1.0" encoding="utf-8"?>
+<p:sld xmlns:a="http://schemas.openxmlformats.org/drawingml/2006/main" xmlns:p="http://schemas.openxmlformats.org/presentationml/2006/main" xmlns:r="http://schemas.openxmlformats.org/officeDocument/2006/relationships">
+  <p:cSld>
+    <p:bg>
+      <p:bgPr>
+        <a:solidFill>
+          <a:srgbClr val="FFFFFF"/>
+        </a:solidFill>
+        <a:effectLst/>
+      </p:bgPr>
+    </p:bg>
+    <p:spTree>
+      <p:nvGrpSpPr>
+        <p:cNvPr id="1" name=""/>
+        <p:cNvGrpSpPr/>
+        <p:nvPr/>
+      </p:nvGrpSpPr>
+      <p:grpSpPr/>
+      <p:sp>
+        <p:nvSpPr>
+          <p:cNvPr id="2" name="Title 1"/>
+          <p:cNvSpPr>
+            <a:spLocks noGrp="1"/>
+          </p:cNvSpPr>
+          <p:nvPr>
+            <p:ph type="title"/>
+          </p:nvPr>
+        </p:nvSpPr>
+        <p:spPr/>
+        <p:txBody>
+          <a:bodyPr/>
+          <a:lstStyle/>
+          <a:p/>
+        </p:txBody>
+      </p:sp>
+      <p:sp>
+        <p:nvSpPr>
+          <p:cNvPr id="3" name="TextBox 2"/>
+          <p:cNvSpPr txBox="1"/>
+          <p:nvPr/>
+        </p:nvSpPr>
+        <p:spPr>
+          <a:xfrm>
+            <a:off x="502920" y="411480"/>
+            <a:ext cx="11247120" cy="731520"/>
+          </a:xfrm>
+          <a:prstGeom prst="rect">
+            <a:avLst/>
+          </a:prstGeom>
+          <a:noFill/>
+        </p:spPr>
+        <p:txBody>
+          <a:bodyPr wrap="square" lIns="0" rIns="0" tIns="0" bIns="0" anchor="t">
+            <a:spAutoFit/>
+          </a:bodyPr>
+          <a:lstStyle/>
+          <a:p>
+            <a:pPr algn="l">
+              <a:lnSpc>
+                <a:spcPct val="115000"/>
+              </a:lnSpc>
+            </a:pPr>
+            <a:r>
+              <a:rPr sz="2800" b="1" i="0">
+                <a:solidFill>
+                  <a:srgbClr val="21295C"/>
+                </a:solidFill>
+                <a:latin typeface="Arial"/>
+              </a:rPr>
+              <a:t>Чат курса в MAX — всё важное в одном месте</a:t>
+            </a:r>
+          </a:p>
+        </p:txBody>
+      </p:sp>
+      <p:sp>
+        <p:nvSpPr>
+          <p:cNvPr id="4" name="TextBox 3"/>
+          <p:cNvSpPr txBox="1"/>
+          <p:nvPr/>
+        </p:nvSpPr>
+        <p:spPr>
+          <a:xfrm>
+            <a:off x="502920" y="1188720"/>
+            <a:ext cx="11247120" cy="457200"/>
+          </a:xfrm>
+          <a:prstGeom prst="rect">
+            <a:avLst/>
+          </a:prstGeom>
+          <a:noFill/>
+        </p:spPr>
+        <p:txBody>
+          <a:bodyPr wrap="square" lIns="0" rIns="0" tIns="0" bIns="0" anchor="t">
+            <a:spAutoFit/>
+          </a:bodyPr>
+          <a:lstStyle/>
+          <a:p>
+            <a:pPr algn="l">
+              <a:lnSpc>
+                <a:spcPct val="115000"/>
+              </a:lnSpc>
+            </a:pPr>
+            <a:r>
+              <a:rPr sz="1700" b="1" i="0">
+                <a:solidFill>
+                  <a:srgbClr val="028090"/>
+                </a:solidFill>
+                <a:latin typeface="Arial"/>
+              </a:rPr>
+              <a:t>Чат группы: «Отраслевое использование ИИ 2026»</a:t>
+            </a:r>
+          </a:p>
+        </p:txBody>
+      </p:sp>
+      <p:sp>
+        <p:nvSpPr>
+          <p:cNvPr id="5" name="Rounded Rectangle 4"/>
+          <p:cNvSpPr/>
+          <p:nvPr/>
+        </p:nvSpPr>
+        <p:spPr>
+          <a:xfrm>
+            <a:off x="822960" y="1783080"/>
+            <a:ext cx="3657600" cy="3977639"/>
+          </a:xfrm>
+          <a:prstGeom prst="roundRect">
+            <a:avLst>
+              <a:gd name="adj" fmla="val 8333"/>
+            </a:avLst>
+          </a:prstGeom>
+          <a:solidFill>
+            <a:srgbClr val="FFFFFF"/>
+          </a:solidFill>
+          <a:ln w="22860">
+            <a:solidFill>
+              <a:srgbClr val="1C7293"/>
+            </a:solidFill>
+          </a:ln>
+          <a:effectLst/>
+        </p:spPr>
+        <p:style>
+          <a:lnRef idx="1">
+            <a:schemeClr val="accent1"/>
+          </a:lnRef>
+          <a:fillRef idx="3">
+            <a:schemeClr val="accent1"/>
+          </a:fillRef>
+          <a:effectRef idx="2">
+            <a:schemeClr val="accent1"/>
+          </a:effectRef>
+          <a:fontRef idx="minor">
+            <a:schemeClr val="lt1"/>
+          </a:fontRef>
+        </p:style>
+        <p:txBody>
+          <a:bodyPr rtlCol="0" anchor="ctr"/>
+          <a:lstStyle/>
+          <a:p>
+            <a:pPr algn="ctr"/>
+          </a:p>
+        </p:txBody>
+      </p:sp>
+      <p:pic>
+        <p:nvPicPr>
+          <p:cNvPr id="6" name="Picture 5" descr="s04b-max-qr.png"/>
+          <p:cNvPicPr>
+            <a:picLocks noChangeAspect="1"/>
+          </p:cNvPicPr>
+          <p:nvPr/>
+        </p:nvPicPr>
+        <p:blipFill>
+          <a:blip r:embed="rId2"/>
+          <a:stretch>
+            <a:fillRect/>
+          </a:stretch>
+        </p:blipFill>
+        <p:spPr>
+          <a:xfrm>
+            <a:off x="1485900" y="2039112"/>
+            <a:ext cx="2331720" cy="2331720"/>
+          </a:xfrm>
+          <a:prstGeom prst="rect">
+            <a:avLst/>
+          </a:prstGeom>
+        </p:spPr>
+      </p:pic>
+      <p:sp>
+        <p:nvSpPr>
+          <p:cNvPr id="7" name="TextBox 6"/>
+          <p:cNvSpPr txBox="1"/>
+          <p:nvPr/>
+        </p:nvSpPr>
+        <p:spPr>
+          <a:xfrm>
+            <a:off x="1005840" y="4507992"/>
+            <a:ext cx="3291840" cy="365760"/>
+          </a:xfrm>
+          <a:prstGeom prst="rect">
+            <a:avLst/>
+          </a:prstGeom>
+          <a:noFill/>
+        </p:spPr>
+        <p:txBody>
+          <a:bodyPr wrap="square" lIns="0" rIns="0" tIns="0" bIns="0" anchor="t">
+            <a:spAutoFit/>
+          </a:bodyPr>
+          <a:lstStyle/>
+          <a:p>
+            <a:pPr algn="ctr">
+              <a:lnSpc>
+                <a:spcPct val="115000"/>
+              </a:lnSpc>
+            </a:pPr>
+            <a:r>
+              <a:rPr sz="1400" b="1" i="0">
+                <a:solidFill>
+                  <a:srgbClr val="21295C"/>
+                </a:solidFill>
+                <a:latin typeface="Arial"/>
+              </a:rPr>
+              <a:t>Отсканируйте камерой телефона</a:t>
+            </a:r>
+          </a:p>
+        </p:txBody>
+      </p:sp>
+      <p:sp>
+        <p:nvSpPr>
+          <p:cNvPr id="8" name="TextBox 7"/>
+          <p:cNvSpPr txBox="1"/>
+          <p:nvPr/>
+        </p:nvSpPr>
+        <p:spPr>
+          <a:xfrm>
+            <a:off x="960120" y="4928616"/>
+            <a:ext cx="3383280" cy="731520"/>
+          </a:xfrm>
+          <a:prstGeom prst="rect">
+            <a:avLst/>
+          </a:prstGeom>
+          <a:noFill/>
+        </p:spPr>
+        <p:txBody>
+          <a:bodyPr wrap="square" lIns="0" rIns="0" tIns="0" bIns="0" anchor="t">
+            <a:spAutoFit/>
+          </a:bodyPr>
+          <a:lstStyle/>
+          <a:p>
+            <a:pPr algn="ctr">
+              <a:lnSpc>
+                <a:spcPct val="112000"/>
+              </a:lnSpc>
+            </a:pPr>
+            <a:r>
+              <a:rPr sz="1000" b="0" i="0">
+                <a:solidFill>
+                  <a:srgbClr val="065A82"/>
+                </a:solidFill>
+                <a:latin typeface="Arial"/>
+              </a:rPr>
+              <a:t>max.ru/join/sHoHlhI4jvW_swcq5ZLowvz6G94m0IMhAwngxuxsEpI</a:t>
+            </a:r>
+          </a:p>
+        </p:txBody>
+      </p:sp>
+      <p:sp>
+        <p:nvSpPr>
+          <p:cNvPr id="9" name="Rounded Rectangle 8"/>
+          <p:cNvSpPr/>
+          <p:nvPr/>
+        </p:nvSpPr>
+        <p:spPr>
+          <a:xfrm>
+            <a:off x="4937760" y="1783080"/>
+            <a:ext cx="6766560" cy="1234440"/>
+          </a:xfrm>
+          <a:prstGeom prst="roundRect">
+            <a:avLst>
+              <a:gd name="adj" fmla="val 24691"/>
+            </a:avLst>
+          </a:prstGeom>
+          <a:solidFill>
+            <a:srgbClr val="F4F7FA"/>
+          </a:solidFill>
+          <a:ln w="19050">
+            <a:solidFill>
+              <a:srgbClr val="1C7293"/>
+            </a:solidFill>
+          </a:ln>
+          <a:effectLst/>
+        </p:spPr>
+        <p:style>
+          <a:lnRef idx="1">
+            <a:schemeClr val="accent1"/>
+          </a:lnRef>
+          <a:fillRef idx="3">
+            <a:schemeClr val="accent1"/>
+          </a:fillRef>
+          <a:effectRef idx="2">
+            <a:schemeClr val="accent1"/>
+          </a:effectRef>
+          <a:fontRef idx="minor">
+            <a:schemeClr val="lt1"/>
+          </a:fontRef>
+        </p:style>
+        <p:txBody>
+          <a:bodyPr rtlCol="0" anchor="ctr"/>
+          <a:lstStyle/>
+          <a:p>
+            <a:pPr algn="ctr"/>
+          </a:p>
+        </p:txBody>
+      </p:sp>
+      <p:sp>
+        <p:nvSpPr>
+          <p:cNvPr id="10" name="Rounded Rectangle 9"/>
+          <p:cNvSpPr/>
+          <p:nvPr/>
+        </p:nvSpPr>
+        <p:spPr>
+          <a:xfrm>
+            <a:off x="5157216" y="2057400"/>
+            <a:ext cx="566928" cy="566928"/>
+          </a:xfrm>
+          <a:prstGeom prst="roundRect">
+            <a:avLst>
+              <a:gd name="adj" fmla="val 26000"/>
+            </a:avLst>
+          </a:prstGeom>
+          <a:solidFill>
+            <a:srgbClr val="028090"/>
+          </a:solidFill>
+          <a:ln>
+            <a:noFill/>
+          </a:ln>
+          <a:effectLst/>
+        </p:spPr>
+        <p:style>
+          <a:lnRef idx="1">
+            <a:schemeClr val="accent1"/>
+          </a:lnRef>
+          <a:fillRef idx="3">
+            <a:schemeClr val="accent1"/>
+          </a:fillRef>
+          <a:effectRef idx="2">
+            <a:schemeClr val="accent1"/>
+          </a:effectRef>
+          <a:fontRef idx="minor">
+            <a:schemeClr val="lt1"/>
+          </a:fontRef>
+        </p:style>
+        <p:txBody>
+          <a:bodyPr rtlCol="0" anchor="ctr"/>
+          <a:lstStyle/>
+          <a:p>
+            <a:pPr algn="ctr"/>
+          </a:p>
+        </p:txBody>
+      </p:sp>
+      <p:pic>
+        <p:nvPicPr>
+          <p:cNvPr id="11" name="Picture 10" descr="bell-FFFFFF-64.png"/>
+          <p:cNvPicPr>
+            <a:picLocks noChangeAspect="1"/>
+          </p:cNvPicPr>
+          <p:nvPr/>
+        </p:nvPicPr>
+        <p:blipFill>
+          <a:blip r:embed="rId3"/>
+          <a:stretch>
+            <a:fillRect/>
+          </a:stretch>
+        </p:blipFill>
+        <p:spPr>
+          <a:xfrm>
+            <a:off x="5259263" y="2159447"/>
+            <a:ext cx="351495" cy="351495"/>
+          </a:xfrm>
+          <a:prstGeom prst="rect">
+            <a:avLst/>
+          </a:prstGeom>
+        </p:spPr>
+      </p:pic>
+      <p:sp>
+        <p:nvSpPr>
+          <p:cNvPr id="12" name="TextBox 11"/>
+          <p:cNvSpPr txBox="1"/>
+          <p:nvPr/>
+        </p:nvSpPr>
+        <p:spPr>
+          <a:xfrm>
+            <a:off x="5989320" y="2002536"/>
+            <a:ext cx="5486400" cy="365760"/>
+          </a:xfrm>
+          <a:prstGeom prst="rect">
+            <a:avLst/>
+          </a:prstGeom>
+          <a:noFill/>
+        </p:spPr>
+        <p:txBody>
+          <a:bodyPr wrap="square" lIns="0" rIns="0" tIns="0" bIns="0" anchor="t">
+            <a:spAutoFit/>
+          </a:bodyPr>
+          <a:lstStyle/>
+          <a:p>
+            <a:pPr algn="l">
+              <a:lnSpc>
+                <a:spcPct val="115000"/>
+              </a:lnSpc>
+            </a:pPr>
+            <a:r>
+              <a:rPr sz="1600" b="1" i="0">
+                <a:solidFill>
+                  <a:srgbClr val="21295C"/>
+                </a:solidFill>
+                <a:latin typeface="Arial"/>
+              </a:rPr>
+              <a:t>Объявления</a:t>
+            </a:r>
+          </a:p>
+        </p:txBody>
+      </p:sp>
+      <p:sp>
+        <p:nvSpPr>
+          <p:cNvPr id="13" name="TextBox 12"/>
+          <p:cNvSpPr txBox="1"/>
+          <p:nvPr/>
+        </p:nvSpPr>
+        <p:spPr>
+          <a:xfrm>
+            <a:off x="5989320" y="2404872"/>
+            <a:ext cx="5486400" cy="502920"/>
+          </a:xfrm>
+          <a:prstGeom prst="rect">
+            <a:avLst/>
+          </a:prstGeom>
+          <a:noFill/>
+        </p:spPr>
+        <p:txBody>
+          <a:bodyPr wrap="square" lIns="0" rIns="0" tIns="0" bIns="0" anchor="t">
+            <a:spAutoFit/>
+          </a:bodyPr>
+          <a:lstStyle/>
+          <a:p>
+            <a:pPr algn="l">
+              <a:lnSpc>
+                <a:spcPct val="112000"/>
+              </a:lnSpc>
+            </a:pPr>
+            <a:r>
+              <a:rPr sz="1250" b="0" i="0">
+                <a:solidFill>
+                  <a:srgbClr val="6B7685"/>
+                </a:solidFill>
+                <a:latin typeface="Arial"/>
+              </a:rPr>
+              <a:t>Расписание, изменения, важные новости курса — в одном месте.</a:t>
+            </a:r>
+          </a:p>
+        </p:txBody>
+      </p:sp>
+      <p:sp>
+        <p:nvSpPr>
+          <p:cNvPr id="14" name="Rounded Rectangle 13"/>
+          <p:cNvSpPr/>
+          <p:nvPr/>
+        </p:nvSpPr>
+        <p:spPr>
+          <a:xfrm>
+            <a:off x="4937760" y="3154680"/>
+            <a:ext cx="6766560" cy="1234440"/>
+          </a:xfrm>
+          <a:prstGeom prst="roundRect">
+            <a:avLst>
+              <a:gd name="adj" fmla="val 24691"/>
+            </a:avLst>
+          </a:prstGeom>
+          <a:solidFill>
+            <a:srgbClr val="F4F7FA"/>
+          </a:solidFill>
+          <a:ln w="19050">
+            <a:solidFill>
+              <a:srgbClr val="1C7293"/>
+            </a:solidFill>
+          </a:ln>
+          <a:effectLst/>
+        </p:spPr>
+        <p:style>
+          <a:lnRef idx="1">
+            <a:schemeClr val="accent1"/>
+          </a:lnRef>
+          <a:fillRef idx="3">
+            <a:schemeClr val="accent1"/>
+          </a:fillRef>
+          <a:effectRef idx="2">
+            <a:schemeClr val="accent1"/>
+          </a:effectRef>
+          <a:fontRef idx="minor">
+            <a:schemeClr val="lt1"/>
+          </a:fontRef>
+        </p:style>
+        <p:txBody>
+          <a:bodyPr rtlCol="0" anchor="ctr"/>
+          <a:lstStyle/>
+          <a:p>
+            <a:pPr algn="ctr"/>
+          </a:p>
+        </p:txBody>
+      </p:sp>
+      <p:sp>
+        <p:nvSpPr>
+          <p:cNvPr id="15" name="Rounded Rectangle 14"/>
+          <p:cNvSpPr/>
+          <p:nvPr/>
+        </p:nvSpPr>
+        <p:spPr>
+          <a:xfrm>
+            <a:off x="5157216" y="3429000"/>
+            <a:ext cx="566928" cy="566928"/>
+          </a:xfrm>
+          <a:prstGeom prst="roundRect">
+            <a:avLst>
+              <a:gd name="adj" fmla="val 26000"/>
+            </a:avLst>
+          </a:prstGeom>
+          <a:solidFill>
+            <a:srgbClr val="028090"/>
+          </a:solidFill>
+          <a:ln>
+            <a:noFill/>
+          </a:ln>
+          <a:effectLst/>
+        </p:spPr>
+        <p:style>
+          <a:lnRef idx="1">
+            <a:schemeClr val="accent1"/>
+          </a:lnRef>
+          <a:fillRef idx="3">
+            <a:schemeClr val="accent1"/>
+          </a:fillRef>
+          <a:effectRef idx="2">
+            <a:schemeClr val="accent1"/>
+          </a:effectRef>
+          <a:fontRef idx="minor">
+            <a:schemeClr val="lt1"/>
+          </a:fontRef>
+        </p:style>
+        <p:txBody>
+          <a:bodyPr rtlCol="0" anchor="ctr"/>
+          <a:lstStyle/>
+          <a:p>
+            <a:pPr algn="ctr"/>
+          </a:p>
+        </p:txBody>
+      </p:sp>
+      <p:pic>
+        <p:nvPicPr>
+          <p:cNvPr id="16" name="Picture 15" descr="book-open-FFFFFF-64.png"/>
+          <p:cNvPicPr>
+            <a:picLocks noChangeAspect="1"/>
+          </p:cNvPicPr>
+          <p:nvPr/>
+        </p:nvPicPr>
+        <p:blipFill>
+          <a:blip r:embed="rId4"/>
+          <a:stretch>
+            <a:fillRect/>
+          </a:stretch>
+        </p:blipFill>
+        <p:spPr>
+          <a:xfrm>
+            <a:off x="5259263" y="3531047"/>
+            <a:ext cx="351495" cy="351495"/>
+          </a:xfrm>
+          <a:prstGeom prst="rect">
+            <a:avLst/>
+          </a:prstGeom>
+        </p:spPr>
+      </p:pic>
+      <p:sp>
+        <p:nvSpPr>
+          <p:cNvPr id="17" name="TextBox 16"/>
+          <p:cNvSpPr txBox="1"/>
+          <p:nvPr/>
+        </p:nvSpPr>
+        <p:spPr>
+          <a:xfrm>
+            <a:off x="5989320" y="3374136"/>
+            <a:ext cx="5486400" cy="365760"/>
+          </a:xfrm>
+          <a:prstGeom prst="rect">
+            <a:avLst/>
+          </a:prstGeom>
+          <a:noFill/>
+        </p:spPr>
+        <p:txBody>
+          <a:bodyPr wrap="square" lIns="0" rIns="0" tIns="0" bIns="0" anchor="t">
+            <a:spAutoFit/>
+          </a:bodyPr>
+          <a:lstStyle/>
+          <a:p>
+            <a:pPr algn="l">
+              <a:lnSpc>
+                <a:spcPct val="115000"/>
+              </a:lnSpc>
+            </a:pPr>
+            <a:r>
+              <a:rPr sz="1600" b="1" i="0">
+                <a:solidFill>
+                  <a:srgbClr val="21295C"/>
+                </a:solidFill>
+                <a:latin typeface="Arial"/>
+              </a:rPr>
+              <a:t>Материалы лекций и семинаров</a:t>
+            </a:r>
+          </a:p>
+        </p:txBody>
+      </p:sp>
+      <p:sp>
+        <p:nvSpPr>
+          <p:cNvPr id="18" name="TextBox 17"/>
+          <p:cNvSpPr txBox="1"/>
+          <p:nvPr/>
+        </p:nvSpPr>
+        <p:spPr>
+          <a:xfrm>
+            <a:off x="5989320" y="3776472"/>
+            <a:ext cx="5486400" cy="502920"/>
+          </a:xfrm>
+          <a:prstGeom prst="rect">
+            <a:avLst/>
+          </a:prstGeom>
+          <a:noFill/>
+        </p:spPr>
+        <p:txBody>
+          <a:bodyPr wrap="square" lIns="0" rIns="0" tIns="0" bIns="0" anchor="t">
+            <a:spAutoFit/>
+          </a:bodyPr>
+          <a:lstStyle/>
+          <a:p>
+            <a:pPr algn="l">
+              <a:lnSpc>
+                <a:spcPct val="112000"/>
+              </a:lnSpc>
+            </a:pPr>
+            <a:r>
+              <a:rPr sz="1250" b="0" i="0">
+                <a:solidFill>
+                  <a:srgbClr val="6B7685"/>
+                </a:solidFill>
+                <a:latin typeface="Arial"/>
+              </a:rPr>
+              <a:t>Слайды и материалы появляются в чате по мере проведения занятий.</a:t>
+            </a:r>
+          </a:p>
+        </p:txBody>
+      </p:sp>
+      <p:sp>
+        <p:nvSpPr>
+          <p:cNvPr id="19" name="Rounded Rectangle 18"/>
+          <p:cNvSpPr/>
+          <p:nvPr/>
+        </p:nvSpPr>
+        <p:spPr>
+          <a:xfrm>
+            <a:off x="4937760" y="4526280"/>
+            <a:ext cx="6766560" cy="1234440"/>
+          </a:xfrm>
+          <a:prstGeom prst="roundRect">
+            <a:avLst>
+              <a:gd name="adj" fmla="val 24691"/>
+            </a:avLst>
+          </a:prstGeom>
+          <a:solidFill>
+            <a:srgbClr val="F4F7FA"/>
+          </a:solidFill>
+          <a:ln w="19050">
+            <a:solidFill>
+              <a:srgbClr val="1C7293"/>
+            </a:solidFill>
+          </a:ln>
+          <a:effectLst/>
+        </p:spPr>
+        <p:style>
+          <a:lnRef idx="1">
+            <a:schemeClr val="accent1"/>
+          </a:lnRef>
+          <a:fillRef idx="3">
+            <a:schemeClr val="accent1"/>
+          </a:fillRef>
+          <a:effectRef idx="2">
+            <a:schemeClr val="accent1"/>
+          </a:effectRef>
+          <a:fontRef idx="minor">
+            <a:schemeClr val="lt1"/>
+          </a:fontRef>
+        </p:style>
+        <p:txBody>
+          <a:bodyPr rtlCol="0" anchor="ctr"/>
+          <a:lstStyle/>
+          <a:p>
+            <a:pPr algn="ctr"/>
+          </a:p>
+        </p:txBody>
+      </p:sp>
+      <p:sp>
+        <p:nvSpPr>
+          <p:cNvPr id="20" name="Rounded Rectangle 19"/>
+          <p:cNvSpPr/>
+          <p:nvPr/>
+        </p:nvSpPr>
+        <p:spPr>
+          <a:xfrm>
+            <a:off x="5157216" y="4800600"/>
+            <a:ext cx="566928" cy="566928"/>
+          </a:xfrm>
+          <a:prstGeom prst="roundRect">
+            <a:avLst>
+              <a:gd name="adj" fmla="val 26000"/>
+            </a:avLst>
+          </a:prstGeom>
+          <a:solidFill>
+            <a:srgbClr val="028090"/>
+          </a:solidFill>
+          <a:ln>
+            <a:noFill/>
+          </a:ln>
+          <a:effectLst/>
+        </p:spPr>
+        <p:style>
+          <a:lnRef idx="1">
+            <a:schemeClr val="accent1"/>
+          </a:lnRef>
+          <a:fillRef idx="3">
+            <a:schemeClr val="accent1"/>
+          </a:fillRef>
+          <a:effectRef idx="2">
+            <a:schemeClr val="accent1"/>
+          </a:effectRef>
+          <a:fontRef idx="minor">
+            <a:schemeClr val="lt1"/>
+          </a:fontRef>
+        </p:style>
+        <p:txBody>
+          <a:bodyPr rtlCol="0" anchor="ctr"/>
+          <a:lstStyle/>
+          <a:p>
+            <a:pPr algn="ctr"/>
+          </a:p>
+        </p:txBody>
+      </p:sp>
+      <p:pic>
+        <p:nvPicPr>
+          <p:cNvPr id="21" name="Picture 20" descr="message-square-quote-FFFFFF-64.png"/>
+          <p:cNvPicPr>
+            <a:picLocks noChangeAspect="1"/>
+          </p:cNvPicPr>
+          <p:nvPr/>
+        </p:nvPicPr>
+        <p:blipFill>
+          <a:blip r:embed="rId5"/>
+          <a:stretch>
+            <a:fillRect/>
+          </a:stretch>
+        </p:blipFill>
+        <p:spPr>
+          <a:xfrm>
+            <a:off x="5259263" y="4902647"/>
+            <a:ext cx="351495" cy="351495"/>
+          </a:xfrm>
+          <a:prstGeom prst="rect">
+            <a:avLst/>
+          </a:prstGeom>
+        </p:spPr>
+      </p:pic>
+      <p:sp>
+        <p:nvSpPr>
+          <p:cNvPr id="22" name="TextBox 21"/>
+          <p:cNvSpPr txBox="1"/>
+          <p:nvPr/>
+        </p:nvSpPr>
+        <p:spPr>
+          <a:xfrm>
+            <a:off x="5989320" y="4745736"/>
+            <a:ext cx="5486400" cy="365760"/>
+          </a:xfrm>
+          <a:prstGeom prst="rect">
+            <a:avLst/>
+          </a:prstGeom>
+          <a:noFill/>
+        </p:spPr>
+        <p:txBody>
+          <a:bodyPr wrap="square" lIns="0" rIns="0" tIns="0" bIns="0" anchor="t">
+            <a:spAutoFit/>
+          </a:bodyPr>
+          <a:lstStyle/>
+          <a:p>
+            <a:pPr algn="l">
+              <a:lnSpc>
+                <a:spcPct val="115000"/>
+              </a:lnSpc>
+            </a:pPr>
+            <a:r>
+              <a:rPr sz="1600" b="1" i="0">
+                <a:solidFill>
+                  <a:srgbClr val="21295C"/>
+                </a:solidFill>
+                <a:latin typeface="Arial"/>
+              </a:rPr>
+              <a:t>Вопросы между занятиями</a:t>
+            </a:r>
+          </a:p>
+        </p:txBody>
+      </p:sp>
+      <p:sp>
+        <p:nvSpPr>
+          <p:cNvPr id="23" name="TextBox 22"/>
+          <p:cNvSpPr txBox="1"/>
+          <p:nvPr/>
+        </p:nvSpPr>
+        <p:spPr>
+          <a:xfrm>
+            <a:off x="5989320" y="5148072"/>
+            <a:ext cx="5486400" cy="502920"/>
+          </a:xfrm>
+          <a:prstGeom prst="rect">
+            <a:avLst/>
+          </a:prstGeom>
+          <a:noFill/>
+        </p:spPr>
+        <p:txBody>
+          <a:bodyPr wrap="square" lIns="0" rIns="0" tIns="0" bIns="0" anchor="t">
+            <a:spAutoFit/>
+          </a:bodyPr>
+          <a:lstStyle/>
+          <a:p>
+            <a:pPr algn="l">
+              <a:lnSpc>
+                <a:spcPct val="112000"/>
+              </a:lnSpc>
+            </a:pPr>
+            <a:r>
+              <a:rPr sz="1250" b="0" i="0">
+                <a:solidFill>
+                  <a:srgbClr val="6B7685"/>
+                </a:solidFill>
+                <a:latin typeface="Arial"/>
+              </a:rPr>
+              <a:t>Можно задать вопрос по курсу и получить ответ, не дожидаясь пары.</a:t>
             </a:r>
           </a:p>
         </p:txBody>

</xml_diff>